<commit_message>
Ajoute les licences : CC BY 4.0 (supports) et MIT (scripts)
Mention de licence sur la page de garde des notes et sur la diapo contact.

Co-Authored-By: Claude Opus 5.5 <noreply@anthropic.com>
</commit_message>
<xml_diff>
--- a/skills-claude-presentation.pptx
+++ b/skills-claude-presentation.pptx
@@ -36664,6 +36664,45 @@
           </a:p>
         </p:txBody>
       </p:sp>
+      <p:sp>
+        <p:nvSpPr>
+          <p:cNvPr id="27" name="Text 18"/>
+          <p:cNvSpPr txBox="1"/>
+          <p:nvPr/>
+        </p:nvSpPr>
+        <p:spPr>
+          <a:xfrm>
+            <a:off x="6675120" y="6355080"/>
+            <a:ext cx="5029200" cy="365760"/>
+          </a:xfrm>
+          <a:prstGeom prst="rect">
+            <a:avLst/>
+          </a:prstGeom>
+          <a:noFill/>
+          <a:ln/>
+        </p:spPr>
+        <p:txBody>
+          <a:bodyPr wrap="square" lIns="0" tIns="0" rIns="0" bIns="0" rtlCol="0" anchor="ctr"/>
+          <a:lstStyle/>
+          <a:p>
+            <a:pPr algn="ctr" indent="0" marL="0">
+              <a:buNone/>
+            </a:pPr>
+            <a:r>
+              <a:rPr lang="fr-FR" altLang="en-US" sz="1400" dirty="0">
+                <a:solidFill>
+                  <a:srgbClr val="AEB5C2"/>
+                </a:solidFill>
+                <a:latin typeface="Calibri" pitchFamily="34" charset="0"/>
+                <a:ea typeface="Calibri" pitchFamily="34" charset="-122"/>
+                <a:cs typeface="Calibri" pitchFamily="34" charset="-120"/>
+              </a:rPr>
+              <a:t>Licence CC BY 4.0 · scripts sous MIT</a:t>
+            </a:r>
+            <a:endParaRPr lang="fr-FR" sz="1400" dirty="0"/>
+          </a:p>
+        </p:txBody>
+      </p:sp>
     </p:spTree>
   </p:cSld>
   <p:clrMapOvr>

</xml_diff>

<commit_message>
Relecture experte : exactitude et bonnes pratiques de création de skills
- Description d'exemple sous 200 caractères, sur une ligne ; règles du nom
- Démo Code : nouvelle session si .claude/skills vient d'être créé
- Mode auto par défaut sur Pro/Max/Team : conseiller Manuel ou Plan
- Enregistrement du fichier de skill ; synchronisation à sens unique
- Tests positifs et négatifs, indice « Using… », fichiers annexes, allowed-tools

Co-Authored-By: Claude Opus 5.5 <noreply@anthropic.com>
</commit_message>
<xml_diff>
--- a/skills-claude-presentation.pptx
+++ b/skills-claude-presentation.pptx
@@ -1008,7 +1008,7 @@
               <a:rPr lang="fr-FR" dirty="0"/>
               <a:t>OBJECTIF — Installer un réflexe de sécurité.
 TIMING — 0:45
-Une skill, ce sont des instructions que Claude va suivre, parfois accompagnées de scripts qu'il exécutera. Une skill malveillante pourrait lui demander d'envoyer vos données ailleurs, ou de faire autre chose que ce qu'annonce son titre. Trois réflexes : je connais l'auteur, ou la source est officielle ; j'ouvre le SKILL.md et je le lis (c'est du texte, ça se lit en deux minutes) ; s'il y a des scripts que je ne comprends pas, je demande à quelqu'un de compétent, ou je demande à Claude de m'expliquer ce qu'ils font avant d'installer. En entreprise, l'offre Enterprise peut analyser automatiquement les skills importées. Ça n'empêche pas de lire.
+Une skill, ce sont des instructions que Claude va suivre, parfois accompagnées de scripts qu'il exécutera. Une skill malveillante pourrait lui demander d'envoyer vos données ailleurs, ou de faire autre chose que ce qu'annonce son titre. Trois réflexes : je connais l'auteur, ou la source est officielle ; j'ouvre le SKILL.md et je le lis (c'est du texte, ça se lit en deux minutes) ; s'il y a des scripts que je ne comprends pas, je demande à quelqu'un de compétent, ou je demande à Claude de m'expliquer ce qu'ils font avant d'installer. Pour Claude Code, un point de plus : l'en-tête d'une skill peut contenir une ligne allowed-tools qui autorise d'avance certaines commandes sans rien vous demander. Si vous la voyez, lisez-la avec attention. En entreprise, l'offre Enterprise peut analyser automatiquement les skills importées. Ça n'empêche pas de lire.
 TRANSITION — Passons à la création. Première question : où ?</a:t>
             </a:r>
             <a:endParaRPr lang="fr-FR" dirty="0"/>
@@ -1189,7 +1189,7 @@
               <a:rPr lang="fr-FR" dirty="0"/>
               <a:t>OBJECTIF — Présenter les trois portes d'entrée et annoncer qu'aucune n'est réservée aux experts.
 TIMING — 1:30
-Trois portes, une même skill. Chat, c'est la conversation classique, sur le web ou dans l'application : vous dites « aide-moi à créer une skill », Claude vous interroge, rédige, et propose de l'enregistrer. Cowork, c'est le mode où Claude travaille dans vos dossiers et produit de vrais fichiers. Petite actualité : Anthropic est en train de fusionner Chat et Cowork en un seul Claude. Selon votre offre, vous verrez encore deux onglets ou un seul (le déploiement a commencé pour Pro et Max, Team et Free suivront, et les administrateurs Enterprise sont prévenus à l'avance). Rien ne se perd : vos skills, projets et connecteurs suivent. Code, enfin, c'est Claude Code. Son nom fait peur, mais c'est simplement Claude qui travaille dans un dossier de votre ordinateur, avec plus de contrôle. Il est disponible dans un onglet de l'application de bureau, sans écran noir ni ligne de commande. Une bonne nouvelle pour finir : une skill enregistrée dans votre compte Claude vous suit dans les trois portes.
+Trois portes, une même skill. Chat, c'est la conversation classique, sur le web ou dans l'application : vous dites « aide-moi à créer une skill », Claude vous interroge, rédige, et vous remet un fichier de skill à enregistrer. Cowork, c'est le mode où Claude travaille dans vos dossiers et produit de vrais fichiers. Petite actualité : Anthropic est en train de fusionner Chat et Cowork en un seul Claude. Selon votre offre, vous verrez encore deux onglets ou un seul (le déploiement a commencé pour Pro et Max, Team et Free suivront, et les administrateurs Enterprise sont prévenus à l'avance). Rien ne se perd : vos skills, projets et connecteurs suivent. Code, enfin, c'est Claude Code. Son nom fait peur, mais c'est simplement Claude qui travaille dans un dossier de votre ordinateur, avec plus de contrôle. Il est disponible dans un onglet de l'application de bureau, sans écran noir ni ligne de commande. Une bonne nouvelle pour finir : une skill enregistrée dans votre compte Claude vous suit dans les trois portes. Attention, la synchronisation va dans un seul sens : une skill créée dans Claude Code reste dans son dossier, et n'apparaît pas dans Chat ou Cowork tant qu'on ne l'a pas importée dans le compte.
 QUESTION À LA SALLE — Qui a déjà utilisé Cowork ? Et Claude Code ? Qui a un peu peur de Claude Code ? (Retenez le nombre de mains : on refera le test à la fin.)
 TRANSITION — Comparons honnêtement ce que chaque porte apporte… et ce qu'elle coûte.</a:t>
             </a:r>
@@ -1281,7 +1281,7 @@
               <a:rPr lang="fr-FR" dirty="0"/>
               <a:t>OBJECTIF — Donner des critères de choix concrets : avantages et limites de chaque porte pour créer une skill.
 TIMING — 3:00
-Chat. Avantages : rien à installer, ça marche dans le navigateur ; Claude vous guide avec sa skill de création de skills et vous pose les bonnes questions ; à la fin, un bouton enregistre la skill dans votre compte. Limites : Claude ne voit pas vos dossiers. Il faut joindre les fichiers un à un, et ajouter plus tard un modèle ou un exemple est moins fluide. Cowork. Avantages : Claude travaille directement dans un dossier de votre ordinateur. Il peut lire votre charte en PDF, vos anciens comptes rendus, vos modèles Word, et produire de vrais fichiers. C'est idéal quand la skill s'appuie sur des documents. Limites : il faut l'application de bureau, et la disponibilité dépend de votre offre (fusion en cours avec Chat). Code. Avantages : Claude voit tout le dossier de la skill, donc SKILL.md, exemples et modèles ensemble ; vous pouvez relire son plan avant qu'il ne touche à quoi que ce soit (le mode plan, j'y reviens) ; la skill est un simple dossier, facile à copier, à versionner et à partager avec une équipe ; enfin, on la teste immédiatement en tapant « / » suivi de son nom. Limites : l'interface impressionne la première fois, et il y a quelques mots nouveaux (dossier de travail, permission). C'est tout. Aucune de ces limites n'est technique : c'est de l'habitude.
+Chat. Avantages : rien à installer, ça marche dans le navigateur ; Claude vous guide avec sa skill de création de skills et vous pose les bonnes questions ; à la fin, il vous remet un fichier de skill, qu'il suffit d'enregistrer dans votre compte. Limites : Claude ne voit pas vos dossiers. Il faut joindre les fichiers un à un, et ajouter plus tard un modèle ou un exemple est moins fluide. Cowork. Avantages : Claude travaille directement dans un dossier de votre ordinateur. Il peut lire votre charte en PDF, vos anciens comptes rendus, vos modèles Word, et produire de vrais fichiers. C'est idéal quand la skill s'appuie sur des documents. Limites : il faut l'application de bureau, et la disponibilité dépend de votre offre (fusion en cours avec Chat). Code. Avantages : Claude voit tout le dossier de la skill, donc SKILL.md, exemples et modèles ensemble ; vous pouvez relire son plan avant qu'il ne touche à quoi que ce soit (le mode plan, j'y reviens) ; la skill est un simple dossier, facile à copier, à versionner et à partager avec une équipe ; enfin, on la teste immédiatement en tapant « / » suivi de son nom. Limites : l'interface impressionne la première fois, et il y a quelques mots nouveaux (dossier de travail, permission). C'est tout. Aucune de ces limites n'est technique : c'est de l'habitude.
 QUESTION À LA SALLE — Pour la skill à laquelle vous pensez depuis le début, quelle porte choisiriez-vous ? Pourquoi ?
 TRANSITION — Justement, parlons de ces peurs autour de Code.</a:t>
             </a:r>
@@ -1373,7 +1373,7 @@
               <a:rPr lang="fr-FR" dirty="0"/>
               <a:t>OBJECTIF — Désamorcer une à une les quatre peurs qui empêchent d'essayer Claude Code.
 TIMING — 2:30
-Quatre idées reçues. Première : « il faut savoir coder ». Non : on écrit à Claude Code exactement comme dans Chat, en français, avec des phrases. Il écrit le SKILL.md pour vous, et c'est du texte. Deuxième : « c'est un écran noir de hacker ». Le terminal existe pour ceux qui l'aiment, mais Claude Code est aussi un onglet de l'application Claude sur ordinateur : une zone de message, un dossier choisi dans une fenêtre, des boutons. Troisième : « je vais tout casser ». Claude Code demande la permission avant de modifier un fichier ou de lancer une commande, et vous pouvez répondre non. Le mode plan va encore plus loin : Claude lit, réfléchit et propose, mais ne modifie rien tant que vous n'avez pas validé. Pour une première fois, travaillez sur une copie de votre dossier : vous ne risquez littéralement rien. Quatrième : « c'est pour les développeurs ». Claude Code fonctionne dans n'importe quel dossier : un dossier de notes, de modèles Word, de comptes rendus. Pour créer une skill, c'est même la porte la plus naturelle, puisqu'une skill… est un dossier.
+Quatre idées reçues. Première : « il faut savoir coder ». Non : on écrit à Claude Code exactement comme dans Chat, en français, avec des phrases. Il écrit le SKILL.md pour vous, et c'est du texte. Deuxième : « c'est un écran noir de hacker ». Le terminal existe pour ceux qui l'aiment, mais Claude Code est aussi un onglet de l'application Claude sur ordinateur : une zone de message, un dossier choisi dans une fenêtre, des boutons. Troisième : « je vais tout casser ». C'est vous qui réglez le niveau de contrôle. Attention : sur les offres Pro, Max et Team, Claude Code démarre en mode auto, où un second modèle vérifie les actions à votre place sans vous demander. Pour une première fois, passez en mode Manuel : Claude demande alors avant chaque modification ou commande, et vous pouvez répondre non. Le mode plan va encore plus loin : Claude lit, réfléchit et propose, mais ne modifie rien tant que vous n'avez pas validé. Pour une première fois, travaillez sur une copie de votre dossier : vous ne risquez littéralement rien. Quatrième : « c'est pour les développeurs ». Claude Code fonctionne dans n'importe quel dossier : un dossier de notes, de modèles Word, de comptes rendus. Pour créer une skill, c'est même la porte la plus naturelle, puisqu'une skill… est un dossier.
 QUESTION À LA SALLE — Laquelle de ces quatre peurs était la vôtre ? Levez la main à chaque carte.
 TRANSITION — Le meilleur antidote à la peur, c'est le mode plan. Voyons comment il marche.</a:t>
             </a:r>
@@ -1649,7 +1649,7 @@
               <a:rPr lang="fr-FR" dirty="0"/>
               <a:t>OBJECTIF — Montrer un parcours complet dans Claude Code, du dossier à la skill testée, en mode plan.
 TIMING — 3:00
-En direct si possible, dans l'onglet Code de l'application de bureau ; sinon, commentez la maquette. Étape 1 : ouvrir un dossier. Ici, « charte » contient la charte graphique en PDF, le logo et un exemple de présentation réussie. Travaillez sur une copie. Étape 2 : passer en mode plan (sélecteur de mode ou Maj + Tab) et écrire : « Crée une skill charte-graphique à partir des fichiers de ce dossier, pour appliquer notre charte à toute présentation ou tout document. » Étape 3 : Claude lit les fichiers et affiche son plan : lire la charte et l'exemple, créer .claude/skills/charte-graphique/SKILL.md, ajouter un fichier de couleurs et de typographie, tester sur une diapo. Lisez-le à voix haute avec la salle et corrigez une chose, pour montrer qu'on garde la main. Étape 4 : approuver en validant chaque modification, pour que la salle voie chaque fichier apparaître. Puis tester : tapez /charte-graphique, ou demandez « fais-moi une diapo de bienvenue ». La skill est rangée dans le dossier .claude/skills du projet : quiconque ouvre ce dossier avec Claude Code en profite. Pour l'avoir aussi dans Claude sur le web, demandez à Claude Code de la compresser en .zip, puis importez-la dans Personnaliser › Skills.
+En direct si possible, dans l'onglet Code de l'application de bureau ; sinon, commentez la maquette. Étape 1 : ouvrir un dossier. Ici, « charte » contient la charte graphique en PDF, le logo et un exemple de présentation réussie. Travaillez sur une copie. Étape 2 : passer en mode plan (sélecteur de mode ou Maj + Tab) et écrire : « Crée une skill charte-graphique à partir des fichiers de ce dossier, pour appliquer notre charte à toute présentation ou tout document. » Étape 3 : Claude lit les fichiers et affiche son plan : lire la charte et l'exemple, créer .claude/skills/charte-graphique/SKILL.md, ajouter un fichier de couleurs et de typographie, tester sur une diapo. Lisez-le à voix haute avec la salle et corrigez une chose, pour montrer qu'on garde la main. Étape 4 : approuver en validant chaque modification, pour que la salle voie chaque fichier apparaître (si la session a démarré en mode auto, c'est l'occasion de montrer qu'on peut choisir ce niveau de contrôle). Point de vigilance : si le dossier .claude/skills vient d'être créé pendant la session, Claude Code ne le voit pas encore. Ouvrez une nouvelle session sur le même dossier avant de tester, ou, mieux, créez ce dossier vide à l'avance dans le dossier de démo. Puis tester : tapez /charte-graphique, ou demandez « fais-moi une diapo de bienvenue ». La skill est rangée dans le dossier .claude/skills du projet : quiconque ouvre ce dossier avec Claude Code en profite. Pour l'avoir aussi dans Claude sur le web, demandez à Claude Code de la compresser en .zip, puis importez-la dans Personnaliser › Skills.
 QUESTION À LA SALLE — Pendant que Claude planifie : « Qu'est-ce que vous voudriez corriger dans ce plan ? »
 TRANSITION — Récapitulons avec une question simple : quelle porte pour moi ?</a:t>
             </a:r>
@@ -1922,7 +1922,7 @@
               <a:rPr lang="fr-FR" dirty="0"/>
               <a:t>OBJECTIF — Donner une méthode simple, réutilisable pendant l'atelier.
 TIMING — 1:00
-Un : repérer une tâche qui revient au moins une fois par semaine et qui se fait toujours de la même façon. Deux : la décrire à Claude comme à un nouveau collègue, avec si possible un exemple réussi (un ancien compte rendu, un mail type). Trois : laisser Claude générer la skill ; il va vous poser des questions, répondez-y franchement. Quatre : tester, dans une nouvelle conversation, avec une demande naturelle, sans nommer la skill. Est-ce qu'elle se déclenche ? Est-ce que le résultat est bon ? Cinq : ajuster. Si elle ne se déclenche pas, c'est presque toujours la description qu'il faut revoir. Si le résultat n'est pas bon, ce sont les instructions ou l'exemple. On boucle entre quatre et cinq deux ou trois fois : c'est normal.
+Un : repérer une tâche qui revient au moins une fois par semaine et qui se fait toujours de la même façon. Deux : la décrire à Claude comme à un nouveau collègue, avec si possible un exemple réussi (un ancien compte rendu, un mail type). Trois : laisser Claude générer la skill ; il va vous poser des questions, répondez-y franchement. Quatre : tester, dans une nouvelle conversation, avec une demande naturelle, sans nommer la skill. Préparez trois demandes : deux qui doivent déclencher la skill, et une qui ne doit pas (par exemple « résume cet article » pour une skill de compte rendu). La mention « Using… » dans la réflexion de Claude indique si la skill a servi. Comparez aussi avec le résultat obtenu sans la skill : c'est ce qui prouve qu'elle apporte quelque chose. Anthropic résume la méthode ainsi : on conçoit avec un premier Claude, on teste avec un second dans une conversation neuve, et on rapporte au premier ce qu'on a observé. Cinq : ajuster. Si elle ne se déclenche pas, c'est presque toujours la description qu'il faut revoir. Si le résultat n'est pas bon, ce sont les instructions ou l'exemple. On boucle entre quatre et cinq deux ou trois fois : c'est normal.
 TRANSITION — Je vous montre à quoi ça ressemble en vrai.</a:t>
             </a:r>
             <a:endParaRPr lang="fr-FR" dirty="0"/>
@@ -2013,7 +2013,7 @@
               <a:rPr lang="fr-FR" dirty="0"/>
               <a:t>OBJECTIF — Démystifier la création par une démonstration courte (en direct, ou sur la maquette si le réseau fait défaut).
 TIMING — 3:00
-Si la connexion le permet, faites la démo en direct dans Chat ; sinon, commentez la maquette. Tapez : « Aide-moi à créer une skill qui transforme mes notes de réunion en compte rendu à notre format. » Claude s'appuie sur sa skill intégrée de création de skills (« skill-creator ») et pose des questions : qui lit ces comptes rendus ? quelle longueur ? avez-vous un exemple ? Répondez, collez un ancien compte rendu réussi. Claude rédige le SKILL.md et vous le montre : faites lire la description à voix haute à la salle. Puis il propose d'enregistrer la skill : un clic, et elle apparaît dans Personnaliser › Skills. Enfin, testez : ouvrez une nouvelle conversation, collez des notes en vrac et dites simplement « tu peux m'en faire un compte rendu ? ». La skill doit se déclencher seule. Si la démo prend du retard, arrêtez-vous après l'enregistrement : le test sera fait pendant l'atelier.
+Si la connexion le permet, faites la démo en direct dans Chat ; sinon, commentez la maquette. Tapez : « Aide-moi à créer une skill qui transforme mes notes de réunion en compte rendu à notre format. » Claude s'appuie sur sa skill intégrée de création de skills (« skill-creator ») et pose des questions : qui lit ces comptes rendus ? quelle longueur ? avez-vous un exemple ? Répondez, collez un ancien compte rendu réussi. Claude rédige le SKILL.md et vous le montre : faites lire la description à voix haute à la salle. Puis il empaquette le tout en un fichier de skill : enregistrez-le (selon la version, un bouton d'enregistrement s'affiche, ou l'on télécharge le fichier et on l'importe avec le bouton « + »), puis vérifiez qu'il est activé dans la liste des skills (Personnaliser › Skills, ou Paramètres › Capacités selon l'interface). Enfin, testez : ouvrez une nouvelle conversation, collez des notes en vrac et dites simplement « tu peux m'en faire un compte rendu ? ». La skill doit se déclencher seule : on le voit à la mention « Using compte-rendu » (utilisation de la skill) dans la réflexion de Claude. Montrez cet indice à la salle, c'est le meilleur moyen de savoir si une skill a été utilisée. Si la démo prend du retard, arrêtez-vous après l'enregistrement : le test sera fait pendant l'atelier.
 QUESTION À LA SALLE — Pendant que Claude rédige : « D'après vous, quelle question va-t-il nous poser ensuite ? »
 TRANSITION — Ce qui fait la différence entre une skill moyenne et une bonne skill tient en trois secrets.</a:t>
             </a:r>
@@ -2105,7 +2105,7 @@
               <a:rPr lang="fr-FR" dirty="0"/>
               <a:t>OBJECTIF — Donner les trois critères de qualité à appliquer dès l'atelier.
 TIMING — 1:15
-Premier secret : la description doit dire QUAND utiliser la skill, pas seulement ce qu'elle fait. « Compte rendu » ne suffit pas. Écrivez plutôt « Rédige un compte rendu de réunion à notre format. Utiliser quand l'utilisateur colle des notes de réunion ou demande un CR, une synthèse de réunion ou un relevé de décisions. » Mettez les mots que vous emploieriez vraiment. Deuxième secret : un exemple réussi vaut dix consignes. Claude imite très bien : donnez-lui un vrai compte rendu que vous aimez. Troisième secret : une skill, une tâche. Mieux vaut trois petites skills claires qu'une grosse skill « tout-en-un » que Claude ne saura pas quand déclencher. Et restez court : si vos instructions dépassent deux pages, c'est souvent qu'il y a deux skills.
+Premier secret : la description doit dire QUAND utiliser la skill, pas seulement ce qu'elle fait. « Compte rendu » ne suffit pas. Écrivez plutôt « Rédige un compte rendu de réunion à notre format. Utiliser quand l'utilisateur colle des notes de réunion ou demande un CR, une synthèse de réunion ou un relevé de décisions. » Écrivez-la comme la notice d'un outil, à la troisième personne (« Rédige… », pas « Je peux t'aider à… »), avec les mots que vos collègues emploient vraiment pour demander cette tâche. Deuxième secret : un exemple réussi vaut dix consignes. Claude imite très bien : donnez-lui un vrai compte rendu que vous aimez. Et dosez la liberté : des consignes souples pour une tâche de jugement (un compte rendu, un mail), des consignes strictes, voire un petit script, quand le résultat doit être identique à chaque fois (une charte graphique, un calcul). Troisième secret : une skill, une tâche. Mieux vaut trois petites skills claires qu'une grosse skill « tout-en-un » que Claude ne saura pas quand déclencher. Et restez concis : Claude est déjà très compétent, n'expliquez que ce qu'il ne peut pas deviner (votre format, vos règles, vos exemples). Si la skill grossit, gardez le SKILL.md court (moins de 500 lignes selon Anthropic) et rangez le détail dans des fichiers annexes que le SKILL.md cite directement, en disant quand les lire. Deux règles de forme : la description tient en 200 caractères maximum dans Claude, et le nom s'écrit en minuscules avec des tirets, sans les mots « claude » ni « anthropic ».
 TRANSITION — Pour finir cette partie, un cas d'usage complet, proposé par Anthropic.</a:t>
             </a:r>
             <a:endParaRPr lang="fr-FR" dirty="0"/>
@@ -2288,7 +2288,7 @@
               <a:rPr lang="fr-FR" dirty="0"/>
               <a:t>OBJECTIF — Relier le cas d'usage aux avantages de chaque porte, et montrer que Code est une option réaliste.
 TIMING — 1:30
-Même objectif, trois chemins. Dans Chat, vous collez le prompt de la page Academy avec vos couleurs et vos règles : Claude crée la skill et vous l'enregistrez. C'est le chemin décrit par la ressource. Dans Cowork, vous pointez le dossier qui contient votre charte en PDF : Claude la lit lui-même, crée la skill et produit une présentation d'exemple pour vérifier. Dans Code, vous faites pareil en mode plan : vous relisez la structure proposée, vous la corrigez, puis Claude écrit les fichiers et vous testez aussitôt avec /charte-graphique. Le résultat est le même : une skill qui applique votre charte partout. Ce qui change, c'est votre niveau de contrôle. Pendant l'atelier, vous pourrez suivre ce cas dans la porte de votre choix.
+Même objectif, trois chemins. Dans Chat, vous collez le prompt de la page Academy avec vos couleurs et vos règles : Claude crée le fichier de skill et vous l'enregistrez dans votre compte. C'est le chemin décrit par la ressource. Dans Cowork, vous pointez le dossier qui contient votre charte en PDF : Claude la lit lui-même, crée la skill et produit une présentation d'exemple pour vérifier. Dans Code, vous faites pareil en mode plan : vous relisez la structure proposée, vous la corrigez, puis Claude écrit les fichiers et vous testez aussitôt avec /charte-graphique. Le résultat est le même : une skill qui applique votre charte partout. Ce qui change, c'est votre niveau de contrôle. Pendant l'atelier, vous pourrez suivre ce cas dans la porte de votre choix.
 TRANSITION — Votre skill fonctionne : comment en faire profiter les autres ?</a:t>
             </a:r>
             <a:endParaRPr lang="fr-FR" dirty="0"/>
@@ -2469,7 +2469,7 @@
               <a:rPr lang="fr-FR" dirty="0"/>
               <a:t>OBJECTIF — Présenter les modes de partage selon l'offre Claude et le public visé.
 TIMING — 2:30
-Premier cercle, vous-même et quelques personnes : dans Personnaliser › Skills, vous pouvez télécharger votre skill en .zip et l'envoyer. Le destinataire l'importe avec le bouton « + ». Ça marche quelle que soit l'offre, gratuite, Pro ou Max. Deuxième cercle, votre équipe : en offre Team ou Enterprise, le menu « … » d'une skill propose « Partager » à des collègues choisis (ils peuvent l'activer, pas la modifier) et « Publier dans l'organisation » pour la rendre disponible à tous. Selon le réglage de l'administrateur, la publication peut passer par une relecture ; les skills fournies par l'administrateur sont activées d'office pour tout le monde. Troisième cercle, tout le monde : on publie le dossier sur GitHub, ou on l'emballe dans un plugin avec d'autres skills. Pour les équipes tech, il suffit aussi de déposer la skill dans le dossier .claude/skills d'un projet de code : toute l'équipe l'aura. Rappel : ce que vous partagez, les autres vont le lire… et Claude va l'exécuter. Relisez avant de publier, et n'y mettez jamais de mot de passe ni de donnée personnelle.
+Premier cercle, vous-même et quelques personnes : on envoie le fichier de la skill (celui que Claude vous a remis à la création, ou un .zip du dossier ; selon la version, le menu de la skill propose aussi de la télécharger, à vérifier le jour J). Le destinataire l'importe avec le bouton « + ». Ça marche quelle que soit l'offre, gratuite, Pro ou Max. Deuxième cercle, votre équipe : en offre Team ou Enterprise, le menu « … » d'une skill propose « Partager » à des collègues choisis (ils peuvent l'activer, pas la modifier) et « Publier dans l'organisation » pour la rendre disponible à tous. Selon le réglage de l'administrateur, la publication peut passer par une relecture ; les skills fournies par l'administrateur sont activées d'office pour tout le monde. Troisième cercle, tout le monde : on publie le dossier sur GitHub, ou on l'emballe dans un plugin avec d'autres skills. Pour les équipes tech, il suffit aussi de déposer la skill dans le dossier .claude/skills d'un projet de code : toute l'équipe l'aura. Rappel : ce que vous partagez, les autres vont le lire… et Claude va l'exécuter. Relisez avant de publier, et n'y mettez jamais de mot de passe ni de donnée personnelle.
 QUESTION À LA SALLE — Dans votre structure, quelle offre avez-vous : individuelle, Team, Enterprise ? Qui est l'administrateur ?
 TRANSITION — Vous avez tout. Sortez vos cartons : c'est l'heure du quiz !</a:t>
             </a:r>
@@ -2835,7 +2835,7 @@
               <a:rPr lang="fr-FR" dirty="0"/>
               <a:t>OBJECTIF — Corriger et consolider la notion de la question 1.
 TIMING — 0:20
-Bonne réponse : B, « Sa description ». Claude lit en permanence la description de chaque skill activée, et elle seule, pour décider s'il ouvre la skill. Une description floue fait une skill qui ne se déclenche jamais, ou qui se déclenche à tort. C'est la phrase la plus importante de la skill.
+Bonne réponse : B, « Sa description ». Claude lit en permanence le nom et la description de chaque skill activée, et c'est la description qui fait l'essentiel du choix. Une description floue fait une skill qui ne se déclenche jamais, ou qui se déclenche à tort. C'est la phrase la plus importante de la skill.
 TRANSITION — Question 2.</a:t>
             </a:r>
             <a:endParaRPr lang="fr-FR" dirty="0"/>
@@ -10020,7 +10020,7 @@
                 <a:ea typeface="Calibri" pitchFamily="34" charset="-122"/>
                 <a:cs typeface="Calibri" pitchFamily="34" charset="-120"/>
               </a:rPr>
-              <a:t>Votre skill vous suit partout.</a:t>
+              <a:t>Skill du compte, disponible partout.</a:t>
             </a:r>
             <a:endParaRPr lang="fr-FR" sz="1800" dirty="0"/>
           </a:p>
@@ -10493,7 +10493,7 @@
                 <a:ea typeface="Calibri" pitchFamily="34" charset="-122"/>
                 <a:cs typeface="Calibri" pitchFamily="34" charset="-120"/>
               </a:rPr>
-              <a:t>Enregistré en 1 clic</a:t>
+              <a:t>Fichier de skill prêt</a:t>
             </a:r>
             <a:endParaRPr lang="fr-FR" sz="1800" dirty="0"/>
           </a:p>
@@ -12403,7 +12403,7 @@
                 <a:ea typeface="Calibri" pitchFamily="34" charset="-122"/>
                 <a:cs typeface="Calibri" pitchFamily="34" charset="-120"/>
               </a:rPr>
-              <a:t>Il demande avant d'agir</a:t>
+              <a:t>Vous choisissez s'il demande</a:t>
             </a:r>
             <a:endParaRPr lang="fr-FR" sz="2200" dirty="0"/>
           </a:p>
@@ -21794,7 +21794,7 @@
                 <a:ea typeface="Calibri" pitchFamily="34" charset="-122"/>
                 <a:cs typeface="Calibri" pitchFamily="34" charset="-120"/>
               </a:rPr>
-              <a:t>Télécharger le .zip et l'envoyer</a:t>
+              <a:t>Envoyer le fichier de la skill</a:t>
             </a:r>
             <a:endParaRPr lang="fr-FR" sz="1800" dirty="0"/>
           </a:p>

</xml_diff>

<commit_message>
Diapo 5 : les trois niveaux de lecture d'une skill (aide Claude)
Métadonnées toujours lues, corps du SKILL.md si utile, fichiers annexes si besoin.

Co-Authored-By: Claude Opus 5.5 <noreply@anthropic.com>
</commit_message>
<xml_diff>
--- a/skills-claude-presentation.pptx
+++ b/skills-claude-presentation.pptx
@@ -4574,9 +4574,9 @@
           <a:p>
             <a:r>
               <a:rPr lang="fr-FR" dirty="0"/>
-              <a:t>OBJECTIF — Donner une image mentale simple et durable de la skill.
-TIMING — 1:15
-Imaginez un classeur de fiches méthode posé à côté de Claude. Sur chaque fiche : un titre, une phrase qui dit quand s'en servir, puis la marche à suivre. Au début de chaque conversation, Claude ne lit que les titres et ces petites phrases. Ça ne lui coûte presque rien, donc vous pouvez avoir beaucoup de fiches. Quand vous demandez « fais-moi le compte rendu de cette réunion », il reconnaît la fiche qui correspond, la sort du classeur et suit la méthode. Les autres fiches restent fermées. C'est ce qui rend les skills efficaces : elles ne surchargent pas Claude, elles arrivent au bon moment. Et vous n'avez pas à y penser : c'est Claude qui va chercher la fiche. Vous pouvez aussi l'appeler vous-même en tapant « / » dans la zone de message.
+              <a:t>OBJECTIF — Donner une image mentale simple et exacte de la façon dont Claude utilise une skill : trois niveaux de lecture.
+TIMING — 1:30
+Imaginez un classeur de fiches méthode posé à côté de Claude. L'aide officielle de Claude décrit précisément comment il s'en sert, en trois niveaux. Niveau 1 : pour chaque skill activée, Claude a toujours sous les yeux le nom et la description, c'est-à-dire l'onglet de la fiche et la phrase qui dit quand s'en servir. Juste assez pour savoir quand la skill est utile, sans charger tout son contenu ; c'est pour cela qu'on peut avoir beaucoup de skills sans encombrer Claude. Niveau 2 : quand votre demande correspond à une description (« fais-moi le compte rendu de cette réunion »), Claude sort la fiche et lit la méthode, le corps du fichier SKILL.md. Niveau 3 : si la méthode ne suffit pas, il consulte les fichiers annexes rangés avec la fiche, un modèle, un exemple, une grille, et seulement ceux dont il a besoin. Les autres fiches restent fermées. Deux conséquences pratiques. D'abord, tout se joue au niveau 1 : une description floue, et la fiche n'est jamais sortie du classeur. Ensuite, on peut mettre beaucoup de détails dans les annexes sans alourdir le travail de Claude, à condition que la méthode dise quand les lire. Vous n'avez rien à faire pour déclencher tout cela : Claude va chercher la fiche tout seul. Vous pouvez aussi l'appeler vous-même en tapant « / » dans la zone de message.
 QUESTION À LA SALLE — Si vous aviez une seule fiche à écrire pour Claude demain matin, ce serait laquelle ?
 TRANSITION — Ouvrons une de ces fiches pour voir ce qu'il y a dedans.</a:t>
             </a:r>
@@ -38117,7 +38117,7 @@
                 <a:ea typeface="Calibri" pitchFamily="34" charset="-122"/>
                 <a:cs typeface="Calibri" pitchFamily="34" charset="-120"/>
               </a:rPr>
-              <a:t>Post LinkedIn</a:t>
+              <a:t>Charte graphique</a:t>
             </a:r>
             <a:endParaRPr lang="fr-FR" sz="1600" dirty="0"/>
           </a:p>
@@ -38210,7 +38210,7 @@
                 <a:ea typeface="Calibri" pitchFamily="34" charset="-122"/>
                 <a:cs typeface="Calibri" pitchFamily="34" charset="-120"/>
               </a:rPr>
-              <a:t>Charte graphique</a:t>
+              <a:t>Mail client</a:t>
             </a:r>
             <a:endParaRPr lang="fr-FR" sz="1600" dirty="0"/>
           </a:p>
@@ -38251,8 +38251,8 @@
         </p:nvSpPr>
         <p:spPr>
           <a:xfrm>
-            <a:off x="3703320" y="3172968"/>
-            <a:ext cx="2103120" cy="457200"/>
+            <a:off x="6126480" y="1801368"/>
+            <a:ext cx="2377440" cy="457200"/>
           </a:xfrm>
           <a:prstGeom prst="roundRect">
             <a:avLst>
@@ -38260,14 +38260,9 @@
             </a:avLst>
           </a:prstGeom>
           <a:solidFill>
-            <a:srgbClr val="E1E5EB"/>
+            <a:srgbClr val="B8235A"/>
           </a:solidFill>
-          <a:ln w="12700">
-            <a:solidFill>
-              <a:srgbClr val="FFFFFF"/>
-            </a:solidFill>
-            <a:prstDash val="solid"/>
-          </a:ln>
+          <a:ln/>
         </p:spPr>
       </p:sp>
       <p:sp>
@@ -38278,8 +38273,8 @@
         </p:nvSpPr>
         <p:spPr>
           <a:xfrm>
-            <a:off x="3813048" y="3172968"/>
-            <a:ext cx="1920240" cy="365760"/>
+            <a:off x="6236208" y="1801368"/>
+            <a:ext cx="2194560" cy="365760"/>
           </a:xfrm>
           <a:prstGeom prst="rect">
             <a:avLst/>
@@ -38297,13 +38292,13 @@
             <a:r>
               <a:rPr lang="fr-FR" altLang="en-US" sz="1600" b="1" dirty="0">
                 <a:solidFill>
-                  <a:srgbClr val="566070"/>
-                </a:solidFill>
-                <a:latin typeface="Calibri" pitchFamily="34" charset="0"/>
-                <a:ea typeface="Calibri" pitchFamily="34" charset="-122"/>
-                <a:cs typeface="Calibri" pitchFamily="34" charset="-120"/>
-              </a:rPr>
-              <a:t>Mail client</a:t>
+                  <a:srgbClr val="FFFFFF"/>
+                </a:solidFill>
+                <a:latin typeface="Courier New" pitchFamily="34" charset="0"/>
+                <a:ea typeface="Courier New" pitchFamily="34" charset="-122"/>
+                <a:cs typeface="Courier New" pitchFamily="34" charset="-120"/>
+              </a:rPr>
+              <a:t>compte-rendu</a:t>
             </a:r>
             <a:endParaRPr lang="fr-FR" sz="1600" dirty="0"/>
           </a:p>
@@ -38317,100 +38312,12 @@
         </p:nvSpPr>
         <p:spPr>
           <a:xfrm>
-            <a:off x="1417320" y="3520440"/>
-            <a:ext cx="4206240" cy="1920240"/>
+            <a:off x="5897880" y="2148840"/>
+            <a:ext cx="3657600" cy="3200400"/>
           </a:xfrm>
           <a:prstGeom prst="roundRect">
             <a:avLst>
-              <a:gd name="adj" fmla="val 5714"/>
-            </a:avLst>
-          </a:prstGeom>
-          <a:solidFill>
-            <a:srgbClr val="F1F3F6"/>
-          </a:solidFill>
-          <a:ln w="12700">
-            <a:solidFill>
-              <a:srgbClr val="D5D9E0"/>
-            </a:solidFill>
-            <a:prstDash val="solid"/>
-          </a:ln>
-        </p:spPr>
-      </p:sp>
-      <p:sp>
-        <p:nvSpPr>
-          <p:cNvPr id="15" name="Shape 13"/>
-          <p:cNvSpPr/>
-          <p:nvPr/>
-        </p:nvSpPr>
-        <p:spPr>
-          <a:xfrm>
-            <a:off x="6492240" y="1801368"/>
-            <a:ext cx="2377440" cy="457200"/>
-          </a:xfrm>
-          <a:prstGeom prst="roundRect">
-            <a:avLst>
-              <a:gd name="adj" fmla="val 20000"/>
-            </a:avLst>
-          </a:prstGeom>
-          <a:solidFill>
-            <a:srgbClr val="B8235A"/>
-          </a:solidFill>
-          <a:ln/>
-        </p:spPr>
-      </p:sp>
-      <p:sp>
-        <p:nvSpPr>
-          <p:cNvPr id="16" name="Text 14"/>
-          <p:cNvSpPr txBox="1"/>
-          <p:nvPr/>
-        </p:nvSpPr>
-        <p:spPr>
-          <a:xfrm>
-            <a:off x="6601968" y="1801368"/>
-            <a:ext cx="2194560" cy="365760"/>
-          </a:xfrm>
-          <a:prstGeom prst="rect">
-            <a:avLst/>
-          </a:prstGeom>
-          <a:noFill/>
-          <a:ln/>
-        </p:spPr>
-        <p:txBody>
-          <a:bodyPr wrap="square" lIns="0" tIns="0" rIns="0" bIns="0" rtlCol="0" anchor="ctr"/>
-          <a:lstStyle/>
-          <a:p>
-            <a:pPr indent="0" marL="0">
-              <a:buNone/>
-            </a:pPr>
-            <a:r>
-              <a:rPr lang="fr-FR" altLang="en-US" sz="1600" b="1" dirty="0">
-                <a:solidFill>
-                  <a:srgbClr val="FFFFFF"/>
-                </a:solidFill>
-                <a:latin typeface="Calibri" pitchFamily="34" charset="0"/>
-                <a:ea typeface="Calibri" pitchFamily="34" charset="-122"/>
-                <a:cs typeface="Calibri" pitchFamily="34" charset="-120"/>
-              </a:rPr>
-              <a:t>Compte rendu</a:t>
-            </a:r>
-            <a:endParaRPr lang="fr-FR" sz="1600" dirty="0"/>
-          </a:p>
-        </p:txBody>
-      </p:sp>
-      <p:sp>
-        <p:nvSpPr>
-          <p:cNvPr id="17" name="Shape 15"/>
-          <p:cNvSpPr/>
-          <p:nvPr/>
-        </p:nvSpPr>
-        <p:spPr>
-          <a:xfrm>
-            <a:off x="6217920" y="2148840"/>
-            <a:ext cx="4937760" cy="3017520"/>
-          </a:xfrm>
-          <a:prstGeom prst="roundRect">
-            <a:avLst>
-              <a:gd name="adj" fmla="val 3636"/>
+              <a:gd name="adj" fmla="val 3429"/>
             </a:avLst>
           </a:prstGeom>
           <a:solidFill>
@@ -38431,9 +38338,185 @@
           </a:effectLst>
         </p:spPr>
       </p:sp>
+      <p:sp>
+        <p:nvSpPr>
+          <p:cNvPr id="15" name="Shape 13"/>
+          <p:cNvSpPr/>
+          <p:nvPr/>
+        </p:nvSpPr>
+        <p:spPr>
+          <a:xfrm>
+            <a:off x="6080760" y="2331720"/>
+            <a:ext cx="3291840" cy="685800"/>
+          </a:xfrm>
+          <a:prstGeom prst="roundRect">
+            <a:avLst>
+              <a:gd name="adj" fmla="val 10667"/>
+            </a:avLst>
+          </a:prstGeom>
+          <a:solidFill>
+            <a:srgbClr val="FBE7EF"/>
+          </a:solidFill>
+          <a:ln/>
+        </p:spPr>
+      </p:sp>
+      <p:sp>
+        <p:nvSpPr>
+          <p:cNvPr id="16" name="Text 14"/>
+          <p:cNvSpPr txBox="1"/>
+          <p:nvPr/>
+        </p:nvSpPr>
+        <p:spPr>
+          <a:xfrm>
+            <a:off x="6217920" y="2331720"/>
+            <a:ext cx="3017520" cy="685800"/>
+          </a:xfrm>
+          <a:prstGeom prst="rect">
+            <a:avLst/>
+          </a:prstGeom>
+          <a:noFill/>
+          <a:ln/>
+        </p:spPr>
+        <p:txBody>
+          <a:bodyPr wrap="square" lIns="0" tIns="0" rIns="0" bIns="0" rtlCol="0" anchor="ctr"/>
+          <a:lstStyle/>
+          <a:p>
+            <a:pPr indent="0" marL="0">
+              <a:buNone/>
+            </a:pPr>
+            <a:r>
+              <a:rPr lang="fr-FR" altLang="en-US" sz="2000" i="1" dirty="0">
+                <a:solidFill>
+                  <a:srgbClr val="B8235A"/>
+                </a:solidFill>
+                <a:latin typeface="Calibri" pitchFamily="34" charset="0"/>
+                <a:ea typeface="Calibri" pitchFamily="34" charset="-122"/>
+                <a:cs typeface="Calibri" pitchFamily="34" charset="-120"/>
+              </a:rPr>
+              <a:t>« Utiliser quand… »</a:t>
+            </a:r>
+            <a:endParaRPr lang="fr-FR" sz="2000" dirty="0"/>
+          </a:p>
+        </p:txBody>
+      </p:sp>
+      <p:sp>
+        <p:nvSpPr>
+          <p:cNvPr id="17" name="Shape 15"/>
+          <p:cNvSpPr/>
+          <p:nvPr/>
+        </p:nvSpPr>
+        <p:spPr>
+          <a:xfrm>
+            <a:off x="6172200" y="3246120"/>
+            <a:ext cx="2926080" cy="128016"/>
+          </a:xfrm>
+          <a:prstGeom prst="roundRect">
+            <a:avLst>
+              <a:gd name="adj" fmla="val 50000"/>
+            </a:avLst>
+          </a:prstGeom>
+          <a:solidFill>
+            <a:srgbClr val="E1E5EB"/>
+          </a:solidFill>
+          <a:ln/>
+        </p:spPr>
+      </p:sp>
+      <p:sp>
+        <p:nvSpPr>
+          <p:cNvPr id="18" name="Shape 16"/>
+          <p:cNvSpPr/>
+          <p:nvPr/>
+        </p:nvSpPr>
+        <p:spPr>
+          <a:xfrm>
+            <a:off x="6172200" y="3538728"/>
+            <a:ext cx="2377440" cy="128016"/>
+          </a:xfrm>
+          <a:prstGeom prst="roundRect">
+            <a:avLst>
+              <a:gd name="adj" fmla="val 50000"/>
+            </a:avLst>
+          </a:prstGeom>
+          <a:solidFill>
+            <a:srgbClr val="E1E5EB"/>
+          </a:solidFill>
+          <a:ln/>
+        </p:spPr>
+      </p:sp>
+      <p:sp>
+        <p:nvSpPr>
+          <p:cNvPr id="19" name="Shape 17"/>
+          <p:cNvSpPr/>
+          <p:nvPr/>
+        </p:nvSpPr>
+        <p:spPr>
+          <a:xfrm>
+            <a:off x="6172200" y="3831336"/>
+            <a:ext cx="3108960" cy="128016"/>
+          </a:xfrm>
+          <a:prstGeom prst="roundRect">
+            <a:avLst>
+              <a:gd name="adj" fmla="val 50000"/>
+            </a:avLst>
+          </a:prstGeom>
+          <a:solidFill>
+            <a:srgbClr val="E1E5EB"/>
+          </a:solidFill>
+          <a:ln/>
+        </p:spPr>
+      </p:sp>
+      <p:sp>
+        <p:nvSpPr>
+          <p:cNvPr id="20" name="Shape 18"/>
+          <p:cNvSpPr/>
+          <p:nvPr/>
+        </p:nvSpPr>
+        <p:spPr>
+          <a:xfrm>
+            <a:off x="6172200" y="4123944"/>
+            <a:ext cx="1920240" cy="128016"/>
+          </a:xfrm>
+          <a:prstGeom prst="roundRect">
+            <a:avLst>
+              <a:gd name="adj" fmla="val 50000"/>
+            </a:avLst>
+          </a:prstGeom>
+          <a:solidFill>
+            <a:srgbClr val="E1E5EB"/>
+          </a:solidFill>
+          <a:ln/>
+        </p:spPr>
+      </p:sp>
+      <p:sp>
+        <p:nvSpPr>
+          <p:cNvPr id="21" name="Shape 19"/>
+          <p:cNvSpPr/>
+          <p:nvPr/>
+        </p:nvSpPr>
+        <p:spPr>
+          <a:xfrm>
+            <a:off x="6080760" y="4572000"/>
+            <a:ext cx="1325880" cy="502920"/>
+          </a:xfrm>
+          <a:prstGeom prst="roundRect">
+            <a:avLst>
+              <a:gd name="adj" fmla="val 14545"/>
+            </a:avLst>
+          </a:prstGeom>
+          <a:solidFill>
+            <a:srgbClr val="F1F3F6"/>
+          </a:solidFill>
+          <a:ln w="12700">
+            <a:solidFill>
+              <a:srgbClr val="D5D9E0"/>
+            </a:solidFill>
+            <a:prstDash val="solid"/>
+          </a:ln>
+        </p:spPr>
+      </p:sp>
       <p:pic>
         <p:nvPicPr>
-          <p:cNvPr id="18" name="Image 0" descr="">
+          <p:cNvPr id="22" name="Image 0" descr="">
             <a:extLst>
               <a:ext uri="{C183D7F6-B498-43B3-948B-1728B52AA6E4}">
                 <adec:decorative xmlns:adec="http://schemas.microsoft.com/office/drawing/2017/decorative" val="1"/>
@@ -38453,8 +38536,8 @@
         </p:blipFill>
         <p:spPr>
           <a:xfrm>
-            <a:off x="6537960" y="2468880"/>
-            <a:ext cx="548640" cy="548640"/>
+            <a:off x="6172200" y="4709160"/>
+            <a:ext cx="228600" cy="228600"/>
           </a:xfrm>
           <a:prstGeom prst="rect">
             <a:avLst/>
@@ -38463,14 +38546,14 @@
       </p:pic>
       <p:sp>
         <p:nvSpPr>
-          <p:cNvPr id="19" name="Text 16"/>
-          <p:cNvSpPr txBox="1"/>
-          <p:nvPr/>
-        </p:nvSpPr>
-        <p:spPr>
-          <a:xfrm>
-            <a:off x="7269480" y="2468880"/>
-            <a:ext cx="3657600" cy="548640"/>
+          <p:cNvPr id="23" name="Text 20"/>
+          <p:cNvSpPr txBox="1"/>
+          <p:nvPr/>
+        </p:nvSpPr>
+        <p:spPr>
+          <a:xfrm>
+            <a:off x="6446520" y="4572000"/>
+            <a:ext cx="914400" cy="502920"/>
           </a:xfrm>
           <a:prstGeom prst="rect">
             <a:avLst/>
@@ -38486,111 +38569,50 @@
               <a:buNone/>
             </a:pPr>
             <a:r>
-              <a:rPr lang="fr-FR" altLang="en-US" sz="2600" b="1" dirty="0">
+              <a:rPr lang="fr-FR" altLang="en-US" sz="1600" dirty="0">
                 <a:solidFill>
                   <a:srgbClr val="1B2233"/>
                 </a:solidFill>
-                <a:latin typeface="Calibri" pitchFamily="34" charset="0"/>
-                <a:ea typeface="Calibri" pitchFamily="34" charset="-122"/>
-                <a:cs typeface="Calibri" pitchFamily="34" charset="-120"/>
-              </a:rPr>
-              <a:t>Compte rendu</a:t>
-            </a:r>
-            <a:endParaRPr lang="fr-FR" sz="2600" dirty="0"/>
-          </a:p>
-        </p:txBody>
-      </p:sp>
-      <p:sp>
-        <p:nvSpPr>
-          <p:cNvPr id="20" name="Shape 17"/>
+                <a:latin typeface="Courier New" pitchFamily="34" charset="0"/>
+                <a:ea typeface="Courier New" pitchFamily="34" charset="-122"/>
+                <a:cs typeface="Courier New" pitchFamily="34" charset="-120"/>
+              </a:rPr>
+              <a:t>cr.docx</a:t>
+            </a:r>
+            <a:endParaRPr lang="fr-FR" sz="1600" dirty="0"/>
+          </a:p>
+        </p:txBody>
+      </p:sp>
+      <p:sp>
+        <p:nvSpPr>
+          <p:cNvPr id="24" name="Shape 21"/>
           <p:cNvSpPr/>
           <p:nvPr/>
         </p:nvSpPr>
         <p:spPr>
           <a:xfrm>
-            <a:off x="6583680" y="3383280"/>
-            <a:ext cx="3566160" cy="146304"/>
+            <a:off x="7516368" y="4572000"/>
+            <a:ext cx="1783080" cy="502920"/>
           </a:xfrm>
           <a:prstGeom prst="roundRect">
             <a:avLst>
-              <a:gd name="adj" fmla="val 50000"/>
+              <a:gd name="adj" fmla="val 14545"/>
             </a:avLst>
           </a:prstGeom>
           <a:solidFill>
-            <a:srgbClr val="E1E5EB"/>
+            <a:srgbClr val="F1F3F6"/>
           </a:solidFill>
-          <a:ln/>
-        </p:spPr>
-      </p:sp>
-      <p:sp>
-        <p:nvSpPr>
-          <p:cNvPr id="21" name="Shape 18"/>
-          <p:cNvSpPr/>
-          <p:nvPr/>
-        </p:nvSpPr>
-        <p:spPr>
-          <a:xfrm>
-            <a:off x="6583680" y="3767328"/>
-            <a:ext cx="2926080" cy="146304"/>
-          </a:xfrm>
-          <a:prstGeom prst="roundRect">
-            <a:avLst>
-              <a:gd name="adj" fmla="val 50000"/>
-            </a:avLst>
-          </a:prstGeom>
-          <a:solidFill>
-            <a:srgbClr val="E1E5EB"/>
-          </a:solidFill>
-          <a:ln/>
-        </p:spPr>
-      </p:sp>
-      <p:sp>
-        <p:nvSpPr>
-          <p:cNvPr id="22" name="Shape 19"/>
-          <p:cNvSpPr/>
-          <p:nvPr/>
-        </p:nvSpPr>
-        <p:spPr>
-          <a:xfrm>
-            <a:off x="6583680" y="4151376"/>
-            <a:ext cx="3840480" cy="146304"/>
-          </a:xfrm>
-          <a:prstGeom prst="roundRect">
-            <a:avLst>
-              <a:gd name="adj" fmla="val 50000"/>
-            </a:avLst>
-          </a:prstGeom>
-          <a:solidFill>
-            <a:srgbClr val="E1E5EB"/>
-          </a:solidFill>
-          <a:ln/>
-        </p:spPr>
-      </p:sp>
-      <p:sp>
-        <p:nvSpPr>
-          <p:cNvPr id="23" name="Shape 20"/>
-          <p:cNvSpPr/>
-          <p:nvPr/>
-        </p:nvSpPr>
-        <p:spPr>
-          <a:xfrm>
-            <a:off x="6583680" y="4535424"/>
-            <a:ext cx="2377440" cy="146304"/>
-          </a:xfrm>
-          <a:prstGeom prst="roundRect">
-            <a:avLst>
-              <a:gd name="adj" fmla="val 50000"/>
-            </a:avLst>
-          </a:prstGeom>
-          <a:solidFill>
-            <a:srgbClr val="E1E5EB"/>
-          </a:solidFill>
-          <a:ln/>
+          <a:ln w="12700">
+            <a:solidFill>
+              <a:srgbClr val="D5D9E0"/>
+            </a:solidFill>
+            <a:prstDash val="solid"/>
+          </a:ln>
         </p:spPr>
       </p:sp>
       <p:pic>
         <p:nvPicPr>
-          <p:cNvPr id="24" name="Image 1" descr="">
+          <p:cNvPr id="25" name="Image 1" descr="">
             <a:extLst>
               <a:ext uri="{C183D7F6-B498-43B3-948B-1728B52AA6E4}">
                 <adec:decorative xmlns:adec="http://schemas.microsoft.com/office/drawing/2017/decorative" val="1"/>
@@ -38610,7 +38632,313 @@
         </p:blipFill>
         <p:spPr>
           <a:xfrm>
-            <a:off x="5486400" y="3383280"/>
+            <a:off x="7607808" y="4709160"/>
+            <a:ext cx="228600" cy="228600"/>
+          </a:xfrm>
+          <a:prstGeom prst="rect">
+            <a:avLst/>
+          </a:prstGeom>
+        </p:spPr>
+      </p:pic>
+      <p:sp>
+        <p:nvSpPr>
+          <p:cNvPr id="26" name="Text 22"/>
+          <p:cNvSpPr txBox="1"/>
+          <p:nvPr/>
+        </p:nvSpPr>
+        <p:spPr>
+          <a:xfrm>
+            <a:off x="7882128" y="4572000"/>
+            <a:ext cx="1371600" cy="502920"/>
+          </a:xfrm>
+          <a:prstGeom prst="rect">
+            <a:avLst/>
+          </a:prstGeom>
+          <a:noFill/>
+          <a:ln/>
+        </p:spPr>
+        <p:txBody>
+          <a:bodyPr wrap="square" lIns="0" tIns="0" rIns="0" bIns="0" rtlCol="0" anchor="ctr"/>
+          <a:lstStyle/>
+          <a:p>
+            <a:pPr indent="0" marL="0">
+              <a:buNone/>
+            </a:pPr>
+            <a:r>
+              <a:rPr lang="fr-FR" altLang="en-US" sz="1600" dirty="0">
+                <a:solidFill>
+                  <a:srgbClr val="1B2233"/>
+                </a:solidFill>
+                <a:latin typeface="Courier New" pitchFamily="34" charset="0"/>
+                <a:ea typeface="Courier New" pitchFamily="34" charset="-122"/>
+                <a:cs typeface="Courier New" pitchFamily="34" charset="-120"/>
+              </a:rPr>
+              <a:t>exemple.md</a:t>
+            </a:r>
+            <a:endParaRPr lang="fr-FR" sz="1600" dirty="0"/>
+          </a:p>
+        </p:txBody>
+      </p:sp>
+      <p:sp>
+        <p:nvSpPr>
+          <p:cNvPr id="27" name="Shape 23"/>
+          <p:cNvSpPr/>
+          <p:nvPr/>
+        </p:nvSpPr>
+        <p:spPr>
+          <a:xfrm>
+            <a:off x="9601200" y="2651760"/>
+            <a:ext cx="320040" cy="0"/>
+          </a:xfrm>
+          <a:prstGeom prst="line">
+            <a:avLst/>
+          </a:prstGeom>
+          <a:noFill/>
+          <a:ln w="19050">
+            <a:solidFill>
+              <a:srgbClr val="B8235A"/>
+            </a:solidFill>
+            <a:prstDash val="solid"/>
+          </a:ln>
+        </p:spPr>
+      </p:sp>
+      <p:sp>
+        <p:nvSpPr>
+          <p:cNvPr id="28" name="Text 24"/>
+          <p:cNvSpPr txBox="1"/>
+          <p:nvPr/>
+        </p:nvSpPr>
+        <p:spPr>
+          <a:xfrm>
+            <a:off x="10012680" y="2331720"/>
+            <a:ext cx="2103120" cy="685800"/>
+          </a:xfrm>
+          <a:prstGeom prst="rect">
+            <a:avLst/>
+          </a:prstGeom>
+          <a:noFill/>
+          <a:ln/>
+        </p:spPr>
+        <p:txBody>
+          <a:bodyPr wrap="square" lIns="0" tIns="0" rIns="0" bIns="0" rtlCol="0" anchor="ctr"/>
+          <a:lstStyle/>
+          <a:p>
+            <a:pPr indent="0" marL="0">
+              <a:buNone/>
+            </a:pPr>
+            <a:r>
+              <a:rPr lang="fr-FR" altLang="en-US" sz="1800" b="1" dirty="0">
+                <a:solidFill>
+                  <a:srgbClr val="B8235A"/>
+                </a:solidFill>
+                <a:latin typeface="Calibri" pitchFamily="34" charset="0"/>
+                <a:ea typeface="Calibri" pitchFamily="34" charset="-122"/>
+                <a:cs typeface="Calibri" pitchFamily="34" charset="-120"/>
+              </a:rPr>
+              <a:t>1 · Toujours lu</a:t>
+            </a:r>
+            <a:endParaRPr lang="fr-FR" sz="1800" dirty="0"/>
+          </a:p>
+          <a:p>
+            <a:pPr indent="0" marL="0">
+              <a:buNone/>
+            </a:pPr>
+            <a:r>
+              <a:rPr lang="fr-FR" altLang="en-US" sz="1600" dirty="0">
+                <a:solidFill>
+                  <a:srgbClr val="566070"/>
+                </a:solidFill>
+                <a:latin typeface="Calibri" pitchFamily="34" charset="0"/>
+                <a:ea typeface="Calibri" pitchFamily="34" charset="-122"/>
+                <a:cs typeface="Calibri" pitchFamily="34" charset="-120"/>
+              </a:rPr>
+              <a:t>nom + description</a:t>
+            </a:r>
+            <a:endParaRPr lang="fr-FR" sz="1800" dirty="0"/>
+          </a:p>
+        </p:txBody>
+      </p:sp>
+      <p:sp>
+        <p:nvSpPr>
+          <p:cNvPr id="29" name="Shape 25"/>
+          <p:cNvSpPr/>
+          <p:nvPr/>
+        </p:nvSpPr>
+        <p:spPr>
+          <a:xfrm>
+            <a:off x="9601200" y="3520440"/>
+            <a:ext cx="320040" cy="0"/>
+          </a:xfrm>
+          <a:prstGeom prst="line">
+            <a:avLst/>
+          </a:prstGeom>
+          <a:noFill/>
+          <a:ln w="19050">
+            <a:solidFill>
+              <a:srgbClr val="C3C9D2"/>
+            </a:solidFill>
+            <a:prstDash val="solid"/>
+          </a:ln>
+        </p:spPr>
+      </p:sp>
+      <p:sp>
+        <p:nvSpPr>
+          <p:cNvPr id="30" name="Text 26"/>
+          <p:cNvSpPr txBox="1"/>
+          <p:nvPr/>
+        </p:nvSpPr>
+        <p:spPr>
+          <a:xfrm>
+            <a:off x="10012680" y="3200400"/>
+            <a:ext cx="2103120" cy="685800"/>
+          </a:xfrm>
+          <a:prstGeom prst="rect">
+            <a:avLst/>
+          </a:prstGeom>
+          <a:noFill/>
+          <a:ln/>
+        </p:spPr>
+        <p:txBody>
+          <a:bodyPr wrap="square" lIns="0" tIns="0" rIns="0" bIns="0" rtlCol="0" anchor="ctr"/>
+          <a:lstStyle/>
+          <a:p>
+            <a:pPr indent="0" marL="0">
+              <a:buNone/>
+            </a:pPr>
+            <a:r>
+              <a:rPr lang="fr-FR" altLang="en-US" sz="1800" b="1" dirty="0">
+                <a:solidFill>
+                  <a:srgbClr val="1B2233"/>
+                </a:solidFill>
+                <a:latin typeface="Calibri" pitchFamily="34" charset="0"/>
+                <a:ea typeface="Calibri" pitchFamily="34" charset="-122"/>
+                <a:cs typeface="Calibri" pitchFamily="34" charset="-120"/>
+              </a:rPr>
+              <a:t>2 · Lu si utile</a:t>
+            </a:r>
+            <a:endParaRPr lang="fr-FR" sz="1800" dirty="0"/>
+          </a:p>
+          <a:p>
+            <a:pPr indent="0" marL="0">
+              <a:buNone/>
+            </a:pPr>
+            <a:r>
+              <a:rPr lang="fr-FR" altLang="en-US" sz="1600" dirty="0">
+                <a:solidFill>
+                  <a:srgbClr val="566070"/>
+                </a:solidFill>
+                <a:latin typeface="Calibri" pitchFamily="34" charset="0"/>
+                <a:ea typeface="Calibri" pitchFamily="34" charset="-122"/>
+                <a:cs typeface="Calibri" pitchFamily="34" charset="-120"/>
+              </a:rPr>
+              <a:t>la méthode</a:t>
+            </a:r>
+            <a:endParaRPr lang="fr-FR" sz="1800" dirty="0"/>
+          </a:p>
+        </p:txBody>
+      </p:sp>
+      <p:sp>
+        <p:nvSpPr>
+          <p:cNvPr id="31" name="Shape 27"/>
+          <p:cNvSpPr/>
+          <p:nvPr/>
+        </p:nvSpPr>
+        <p:spPr>
+          <a:xfrm>
+            <a:off x="9601200" y="4846320"/>
+            <a:ext cx="320040" cy="0"/>
+          </a:xfrm>
+          <a:prstGeom prst="line">
+            <a:avLst/>
+          </a:prstGeom>
+          <a:noFill/>
+          <a:ln w="19050">
+            <a:solidFill>
+              <a:srgbClr val="C3C9D2"/>
+            </a:solidFill>
+            <a:prstDash val="solid"/>
+          </a:ln>
+        </p:spPr>
+      </p:sp>
+      <p:sp>
+        <p:nvSpPr>
+          <p:cNvPr id="32" name="Text 28"/>
+          <p:cNvSpPr txBox="1"/>
+          <p:nvPr/>
+        </p:nvSpPr>
+        <p:spPr>
+          <a:xfrm>
+            <a:off x="10012680" y="4526280"/>
+            <a:ext cx="2103120" cy="685800"/>
+          </a:xfrm>
+          <a:prstGeom prst="rect">
+            <a:avLst/>
+          </a:prstGeom>
+          <a:noFill/>
+          <a:ln/>
+        </p:spPr>
+        <p:txBody>
+          <a:bodyPr wrap="square" lIns="0" tIns="0" rIns="0" bIns="0" rtlCol="0" anchor="ctr"/>
+          <a:lstStyle/>
+          <a:p>
+            <a:pPr indent="0" marL="0">
+              <a:buNone/>
+            </a:pPr>
+            <a:r>
+              <a:rPr lang="fr-FR" altLang="en-US" sz="1800" b="1" dirty="0">
+                <a:solidFill>
+                  <a:srgbClr val="1B2233"/>
+                </a:solidFill>
+                <a:latin typeface="Calibri" pitchFamily="34" charset="0"/>
+                <a:ea typeface="Calibri" pitchFamily="34" charset="-122"/>
+                <a:cs typeface="Calibri" pitchFamily="34" charset="-120"/>
+              </a:rPr>
+              <a:t>3 · Si besoin</a:t>
+            </a:r>
+            <a:endParaRPr lang="fr-FR" sz="1800" dirty="0"/>
+          </a:p>
+          <a:p>
+            <a:pPr indent="0" marL="0">
+              <a:buNone/>
+            </a:pPr>
+            <a:r>
+              <a:rPr lang="fr-FR" altLang="en-US" sz="1600" dirty="0">
+                <a:solidFill>
+                  <a:srgbClr val="566070"/>
+                </a:solidFill>
+                <a:latin typeface="Calibri" pitchFamily="34" charset="0"/>
+                <a:ea typeface="Calibri" pitchFamily="34" charset="-122"/>
+                <a:cs typeface="Calibri" pitchFamily="34" charset="-120"/>
+              </a:rPr>
+              <a:t>les annexes</a:t>
+            </a:r>
+            <a:endParaRPr lang="fr-FR" sz="1800" dirty="0"/>
+          </a:p>
+        </p:txBody>
+      </p:sp>
+      <p:pic>
+        <p:nvPicPr>
+          <p:cNvPr id="33" name="Image 2" descr="">
+            <a:extLst>
+              <a:ext uri="{C183D7F6-B498-43B3-948B-1728B52AA6E4}">
+                <adec:decorative xmlns:adec="http://schemas.microsoft.com/office/drawing/2017/decorative" val="1"/>
+              </a:ext>
+            </a:extLst>
+          </p:cNvPr>
+          <p:cNvPicPr>
+            <a:picLocks noChangeAspect="1"/>
+          </p:cNvPicPr>
+          <p:nvPr/>
+        </p:nvPicPr>
+        <p:blipFill>
+          <a:blip r:embed="rId3"/>
+          <a:stretch>
+            <a:fillRect/>
+          </a:stretch>
+        </p:blipFill>
+        <p:spPr>
+          <a:xfrm>
+            <a:off x="5257800" y="3383280"/>
             <a:ext cx="548640" cy="548640"/>
           </a:xfrm>
           <a:prstGeom prst="rect">
@@ -38620,7 +38948,7 @@
       </p:pic>
       <p:sp>
         <p:nvSpPr>
-          <p:cNvPr id="25" name="Text 21"/>
+          <p:cNvPr id="34" name="Text 29"/>
           <p:cNvSpPr txBox="1"/>
           <p:nvPr/>
         </p:nvSpPr>
@@ -38651,7 +38979,7 @@
                 <a:ea typeface="Calibri" pitchFamily="34" charset="-122"/>
                 <a:cs typeface="Calibri" pitchFamily="34" charset="-120"/>
               </a:rPr>
-              <a:t>Claude lit les titres… et n'ouvre que la bonne fiche.</a:t>
+              <a:t>Claude n'ouvre que ce qui sert.</a:t>
             </a:r>
             <a:endParaRPr lang="fr-FR" sz="2600" dirty="0"/>
           </a:p>
@@ -38659,7 +38987,7 @@
       </p:sp>
       <p:sp>
         <p:nvSpPr>
-          <p:cNvPr id="26" name="Text 22"/>
+          <p:cNvPr id="35" name="Text 30"/>
           <p:cNvSpPr txBox="1"/>
           <p:nvPr/>
         </p:nvSpPr>
@@ -38698,7 +39026,7 @@
       </p:sp>
       <p:sp>
         <p:nvSpPr>
-          <p:cNvPr id="27" name="Text 23"/>
+          <p:cNvPr id="36" name="Text 31"/>
           <p:cNvSpPr txBox="1"/>
           <p:nvPr/>
         </p:nvSpPr>

</xml_diff>

<commit_message>
Notes présentateur : durée d'ouverture, déroulé et transition vers skill-creator
Co-Authored-By: Claude Opus 5.5 <noreply@anthropic.com>
</commit_message>
<xml_diff>
--- a/skills-claude-presentation.pptx
+++ b/skills-claude-presentation.pptx
@@ -555,7 +555,7 @@
               <a:rPr lang="fr-FR" dirty="0"/>
               <a:t>OBJECTIF — Accueillir, poser le cadre et annoncer la promesse de la séance.
 TIMING — 0:30
-Bonjour à toutes et à tous. Pendant trente minutes, on va parler d'une fonction de Claude qui change la façon de travailler avec lui : les skills, qu'on peut traduire par « compétences ». Pas besoin de savoir coder : si vous savez expliquer une tâche à un nouveau collègue, vous savez créer une skill. Le déroulé : d'abord comprendre ce que c'est, ensuite voir où en trouver, puis comment en créer et en partager une. On finit par un petit quiz où vous répondrez à voix haute, et juste après, vous passez à la pratique sur vos propres cas.
+Bonjour à toutes et à tous. Pendant une petite heure, on va parler d'une fonction de Claude qui change la façon de travailler avec lui : les skills, qu'on peut traduire par « compétences ». Pas besoin de savoir coder : si vous savez expliquer une tâche à un nouveau collègue, vous savez créer une skill. Le déroulé : d'abord comprendre ce que c'est, ensuite voir où en trouver, puis choisir où la créer (Chat, Cowork ou Code, avec le mode plan pour ne rien casser), la créer avec skill-creator, la skill d'Anthropic qui fabrique les skills, et enfin la partager. On finit par un petit quiz où vous répondrez à voix haute, et juste après, vous passez à la pratique sur vos propres cas.
 QUESTION À LA SALLE — À main levée : qui utilise Claude au moins une fois par semaine ?
 TRANSITION — Je commence par une question qui fâche un peu…</a:t>
             </a:r>
@@ -1835,7 +1835,7 @@
               <a:t>OBJECTIF — Donner une méthode simple, réutilisable pendant l'atelier.
 TIMING — 1:00
 Un : repérer une tâche qui revient au moins une fois par semaine et qui se fait toujours de la même façon. Deux : la décrire à Claude comme à un nouveau collègue, avec si possible un exemple réussi (un ancien compte rendu, un mail type). Trois : laisser Claude générer la skill. Il s'appuie pour cela sur skill-creator, la skill d'Anthropic qui fabrique les skills : elle lui fait poser les bonnes questions, puis rédiger un SKILL.md conforme aux bonnes pratiques. Répondez-lui franchement. Quatre : tester, dans une nouvelle conversation, avec une demande naturelle, sans nommer la skill. Préparez trois demandes : deux qui doivent déclencher la skill, et une qui ne doit pas (par exemple « résume cet article » pour une skill de compte rendu). La mention « Using… » dans la réflexion de Claude indique si la skill a servi. Choisissez des demandes réalistes et un peu substantielles : Claude ne consulte pas une skill pour une tâche qu'il sait faire seul en une étape (« lis ce fichier »), même si la description correspond. Comparez aussi avec le résultat obtenu sans la skill : c'est ce qui prouve qu'elle apporte quelque chose. Anthropic résume la méthode ainsi : on conçoit avec un premier Claude, on teste avec un second dans une conversation neuve, et on rapporte au premier ce qu'on a observé. Cinq : ajuster. Si elle ne se déclenche pas, c'est presque toujours la description qu'il faut revoir. Si le résultat n'est pas bon, ce sont les instructions ou l'exemple. On boucle entre quatre et cinq deux ou trois fois : c'est normal.
-TRANSITION — Je vous montre à quoi ça ressemble en vrai.</a:t>
+TRANSITION — L'étape 3, concrètement, qui la fait ? Une skill : skill-creator.</a:t>
             </a:r>
             <a:endParaRPr lang="fr-FR" dirty="0"/>
           </a:p>

</xml_diff>